<commit_message>
He añadido a la presentacion los gifs
</commit_message>
<xml_diff>
--- a/Documentación/Granjero Extranjero.pptx
+++ b/Documentación/Granjero Extranjero.pptx
@@ -15758,10 +15758,642 @@
               <a:buNone/>
             </a:pPr>
             <a:r>
-              <a:rPr lang="es"/>
+              <a:rPr lang="es" dirty="0"/>
               <a:t>Lo avanzado hasta el momento:</a:t>
             </a:r>
-            <a:endParaRPr/>
+            <a:endParaRPr dirty="0"/>
+          </a:p>
+        </p:txBody>
+      </p:sp>
+      <p:pic>
+        <p:nvPicPr>
+          <p:cNvPr id="4" name="Imagen 3">
+            <a:extLst>
+              <a:ext uri="{FF2B5EF4-FFF2-40B4-BE49-F238E27FC236}">
+                <a16:creationId xmlns:a16="http://schemas.microsoft.com/office/drawing/2014/main" id="{26B6C065-C179-1B0A-CD1E-5E4B0CA8CF27}"/>
+              </a:ext>
+            </a:extLst>
+          </p:cNvPr>
+          <p:cNvPicPr>
+            <a:picLocks noChangeAspect="1"/>
+          </p:cNvPicPr>
+          <p:nvPr/>
+        </p:nvPicPr>
+        <p:blipFill>
+          <a:blip r:embed="rId3"/>
+          <a:stretch>
+            <a:fillRect/>
+          </a:stretch>
+        </p:blipFill>
+        <p:spPr>
+          <a:xfrm>
+            <a:off x="5064821" y="2023061"/>
+            <a:ext cx="3555342" cy="1883625"/>
+          </a:xfrm>
+          <a:prstGeom prst="rect">
+            <a:avLst/>
+          </a:prstGeom>
+        </p:spPr>
+      </p:pic>
+      <p:pic>
+        <p:nvPicPr>
+          <p:cNvPr id="6" name="Imagen 5" descr="Pantalla de computadora con fondo azul&#10;&#10;El contenido generado por IA puede ser incorrecto.">
+            <a:extLst>
+              <a:ext uri="{FF2B5EF4-FFF2-40B4-BE49-F238E27FC236}">
+                <a16:creationId xmlns:a16="http://schemas.microsoft.com/office/drawing/2014/main" id="{9D1B0FE2-CEBC-878E-F629-83B62421EDD9}"/>
+              </a:ext>
+            </a:extLst>
+          </p:cNvPr>
+          <p:cNvPicPr>
+            <a:picLocks noChangeAspect="1"/>
+          </p:cNvPicPr>
+          <p:nvPr/>
+        </p:nvPicPr>
+        <p:blipFill>
+          <a:blip r:embed="rId4"/>
+          <a:stretch>
+            <a:fillRect/>
+          </a:stretch>
+        </p:blipFill>
+        <p:spPr>
+          <a:xfrm>
+            <a:off x="523837" y="2023061"/>
+            <a:ext cx="3555343" cy="1883625"/>
+          </a:xfrm>
+          <a:prstGeom prst="rect">
+            <a:avLst/>
+          </a:prstGeom>
+        </p:spPr>
+      </p:pic>
+      <p:sp>
+        <p:nvSpPr>
+          <p:cNvPr id="7" name="Google Shape;293;p15">
+            <a:extLst>
+              <a:ext uri="{FF2B5EF4-FFF2-40B4-BE49-F238E27FC236}">
+                <a16:creationId xmlns:a16="http://schemas.microsoft.com/office/drawing/2014/main" id="{BE72FEBF-88B2-E9EA-7992-F2F414ADA089}"/>
+              </a:ext>
+            </a:extLst>
+          </p:cNvPr>
+          <p:cNvSpPr txBox="1">
+            <a:spLocks/>
+          </p:cNvSpPr>
+          <p:nvPr/>
+        </p:nvSpPr>
+        <p:spPr>
+          <a:xfrm>
+            <a:off x="667407" y="1597875"/>
+            <a:ext cx="3268201" cy="425186"/>
+          </a:xfrm>
+          <a:prstGeom prst="rect">
+            <a:avLst/>
+          </a:prstGeom>
+          <a:noFill/>
+          <a:ln>
+            <a:noFill/>
+          </a:ln>
+        </p:spPr>
+        <p:txBody>
+          <a:bodyPr spcFirstLastPara="1" wrap="square" lIns="91425" tIns="91425" rIns="91425" bIns="91425" anchor="t" anchorCtr="0">
+            <a:normAutofit fontScale="55000" lnSpcReduction="20000"/>
+          </a:bodyPr>
+          <a:lstStyle>
+            <a:defPPr marR="0" lvl="0" algn="l" rtl="0">
+              <a:lnSpc>
+                <a:spcPct val="100000"/>
+              </a:lnSpc>
+              <a:spcBef>
+                <a:spcPts val="0"/>
+              </a:spcBef>
+              <a:spcAft>
+                <a:spcPts val="0"/>
+              </a:spcAft>
+            </a:defPPr>
+            <a:lvl1pPr marR="0" lvl="0" algn="l" rtl="0">
+              <a:lnSpc>
+                <a:spcPct val="100000"/>
+              </a:lnSpc>
+              <a:spcBef>
+                <a:spcPts val="0"/>
+              </a:spcBef>
+              <a:spcAft>
+                <a:spcPts val="0"/>
+              </a:spcAft>
+              <a:buClr>
+                <a:schemeClr val="dk2"/>
+              </a:buClr>
+              <a:buSzPts val="2800"/>
+              <a:buFont typeface="Maven Pro"/>
+              <a:buNone/>
+              <a:defRPr sz="2800" b="1" i="0" u="none" strike="noStrike" cap="none">
+                <a:solidFill>
+                  <a:schemeClr val="dk2"/>
+                </a:solidFill>
+                <a:latin typeface="Maven Pro"/>
+                <a:ea typeface="Maven Pro"/>
+                <a:cs typeface="Maven Pro"/>
+                <a:sym typeface="Maven Pro"/>
+              </a:defRPr>
+            </a:lvl1pPr>
+            <a:lvl2pPr marR="0" lvl="1" algn="l" rtl="0">
+              <a:lnSpc>
+                <a:spcPct val="100000"/>
+              </a:lnSpc>
+              <a:spcBef>
+                <a:spcPts val="0"/>
+              </a:spcBef>
+              <a:spcAft>
+                <a:spcPts val="0"/>
+              </a:spcAft>
+              <a:buClr>
+                <a:schemeClr val="dk2"/>
+              </a:buClr>
+              <a:buSzPts val="2800"/>
+              <a:buFont typeface="Maven Pro"/>
+              <a:buNone/>
+              <a:defRPr sz="2800" b="1" i="0" u="none" strike="noStrike" cap="none">
+                <a:solidFill>
+                  <a:schemeClr val="dk2"/>
+                </a:solidFill>
+                <a:latin typeface="Maven Pro"/>
+                <a:ea typeface="Maven Pro"/>
+                <a:cs typeface="Maven Pro"/>
+                <a:sym typeface="Maven Pro"/>
+              </a:defRPr>
+            </a:lvl2pPr>
+            <a:lvl3pPr marR="0" lvl="2" algn="l" rtl="0">
+              <a:lnSpc>
+                <a:spcPct val="100000"/>
+              </a:lnSpc>
+              <a:spcBef>
+                <a:spcPts val="0"/>
+              </a:spcBef>
+              <a:spcAft>
+                <a:spcPts val="0"/>
+              </a:spcAft>
+              <a:buClr>
+                <a:schemeClr val="dk2"/>
+              </a:buClr>
+              <a:buSzPts val="2800"/>
+              <a:buFont typeface="Maven Pro"/>
+              <a:buNone/>
+              <a:defRPr sz="2800" b="1" i="0" u="none" strike="noStrike" cap="none">
+                <a:solidFill>
+                  <a:schemeClr val="dk2"/>
+                </a:solidFill>
+                <a:latin typeface="Maven Pro"/>
+                <a:ea typeface="Maven Pro"/>
+                <a:cs typeface="Maven Pro"/>
+                <a:sym typeface="Maven Pro"/>
+              </a:defRPr>
+            </a:lvl3pPr>
+            <a:lvl4pPr marR="0" lvl="3" algn="l" rtl="0">
+              <a:lnSpc>
+                <a:spcPct val="100000"/>
+              </a:lnSpc>
+              <a:spcBef>
+                <a:spcPts val="0"/>
+              </a:spcBef>
+              <a:spcAft>
+                <a:spcPts val="0"/>
+              </a:spcAft>
+              <a:buClr>
+                <a:schemeClr val="dk2"/>
+              </a:buClr>
+              <a:buSzPts val="2800"/>
+              <a:buFont typeface="Maven Pro"/>
+              <a:buNone/>
+              <a:defRPr sz="2800" b="1" i="0" u="none" strike="noStrike" cap="none">
+                <a:solidFill>
+                  <a:schemeClr val="dk2"/>
+                </a:solidFill>
+                <a:latin typeface="Maven Pro"/>
+                <a:ea typeface="Maven Pro"/>
+                <a:cs typeface="Maven Pro"/>
+                <a:sym typeface="Maven Pro"/>
+              </a:defRPr>
+            </a:lvl4pPr>
+            <a:lvl5pPr marR="0" lvl="4" algn="l" rtl="0">
+              <a:lnSpc>
+                <a:spcPct val="100000"/>
+              </a:lnSpc>
+              <a:spcBef>
+                <a:spcPts val="0"/>
+              </a:spcBef>
+              <a:spcAft>
+                <a:spcPts val="0"/>
+              </a:spcAft>
+              <a:buClr>
+                <a:schemeClr val="dk2"/>
+              </a:buClr>
+              <a:buSzPts val="2800"/>
+              <a:buFont typeface="Maven Pro"/>
+              <a:buNone/>
+              <a:defRPr sz="2800" b="1" i="0" u="none" strike="noStrike" cap="none">
+                <a:solidFill>
+                  <a:schemeClr val="dk2"/>
+                </a:solidFill>
+                <a:latin typeface="Maven Pro"/>
+                <a:ea typeface="Maven Pro"/>
+                <a:cs typeface="Maven Pro"/>
+                <a:sym typeface="Maven Pro"/>
+              </a:defRPr>
+            </a:lvl5pPr>
+            <a:lvl6pPr marR="0" lvl="5" algn="l" rtl="0">
+              <a:lnSpc>
+                <a:spcPct val="100000"/>
+              </a:lnSpc>
+              <a:spcBef>
+                <a:spcPts val="0"/>
+              </a:spcBef>
+              <a:spcAft>
+                <a:spcPts val="0"/>
+              </a:spcAft>
+              <a:buClr>
+                <a:schemeClr val="dk2"/>
+              </a:buClr>
+              <a:buSzPts val="2800"/>
+              <a:buFont typeface="Maven Pro"/>
+              <a:buNone/>
+              <a:defRPr sz="2800" b="1" i="0" u="none" strike="noStrike" cap="none">
+                <a:solidFill>
+                  <a:schemeClr val="dk2"/>
+                </a:solidFill>
+                <a:latin typeface="Maven Pro"/>
+                <a:ea typeface="Maven Pro"/>
+                <a:cs typeface="Maven Pro"/>
+                <a:sym typeface="Maven Pro"/>
+              </a:defRPr>
+            </a:lvl6pPr>
+            <a:lvl7pPr marR="0" lvl="6" algn="l" rtl="0">
+              <a:lnSpc>
+                <a:spcPct val="100000"/>
+              </a:lnSpc>
+              <a:spcBef>
+                <a:spcPts val="0"/>
+              </a:spcBef>
+              <a:spcAft>
+                <a:spcPts val="0"/>
+              </a:spcAft>
+              <a:buClr>
+                <a:schemeClr val="dk2"/>
+              </a:buClr>
+              <a:buSzPts val="2800"/>
+              <a:buFont typeface="Maven Pro"/>
+              <a:buNone/>
+              <a:defRPr sz="2800" b="1" i="0" u="none" strike="noStrike" cap="none">
+                <a:solidFill>
+                  <a:schemeClr val="dk2"/>
+                </a:solidFill>
+                <a:latin typeface="Maven Pro"/>
+                <a:ea typeface="Maven Pro"/>
+                <a:cs typeface="Maven Pro"/>
+                <a:sym typeface="Maven Pro"/>
+              </a:defRPr>
+            </a:lvl7pPr>
+            <a:lvl8pPr marR="0" lvl="7" algn="l" rtl="0">
+              <a:lnSpc>
+                <a:spcPct val="100000"/>
+              </a:lnSpc>
+              <a:spcBef>
+                <a:spcPts val="0"/>
+              </a:spcBef>
+              <a:spcAft>
+                <a:spcPts val="0"/>
+              </a:spcAft>
+              <a:buClr>
+                <a:schemeClr val="dk2"/>
+              </a:buClr>
+              <a:buSzPts val="2800"/>
+              <a:buFont typeface="Maven Pro"/>
+              <a:buNone/>
+              <a:defRPr sz="2800" b="1" i="0" u="none" strike="noStrike" cap="none">
+                <a:solidFill>
+                  <a:schemeClr val="dk2"/>
+                </a:solidFill>
+                <a:latin typeface="Maven Pro"/>
+                <a:ea typeface="Maven Pro"/>
+                <a:cs typeface="Maven Pro"/>
+                <a:sym typeface="Maven Pro"/>
+              </a:defRPr>
+            </a:lvl8pPr>
+            <a:lvl9pPr marR="0" lvl="8" algn="l" rtl="0">
+              <a:lnSpc>
+                <a:spcPct val="100000"/>
+              </a:lnSpc>
+              <a:spcBef>
+                <a:spcPts val="0"/>
+              </a:spcBef>
+              <a:spcAft>
+                <a:spcPts val="0"/>
+              </a:spcAft>
+              <a:buClr>
+                <a:schemeClr val="dk2"/>
+              </a:buClr>
+              <a:buSzPts val="2800"/>
+              <a:buFont typeface="Maven Pro"/>
+              <a:buNone/>
+              <a:defRPr sz="2800" b="1" i="0" u="none" strike="noStrike" cap="none">
+                <a:solidFill>
+                  <a:schemeClr val="dk2"/>
+                </a:solidFill>
+                <a:latin typeface="Maven Pro"/>
+                <a:ea typeface="Maven Pro"/>
+                <a:cs typeface="Maven Pro"/>
+                <a:sym typeface="Maven Pro"/>
+              </a:defRPr>
+            </a:lvl9pPr>
+          </a:lstStyle>
+          <a:p>
+            <a:r>
+              <a:rPr lang="es-ES" dirty="0"/>
+              <a:t>Script movimiento del Personaje</a:t>
+            </a:r>
+          </a:p>
+        </p:txBody>
+      </p:sp>
+      <p:sp>
+        <p:nvSpPr>
+          <p:cNvPr id="8" name="Google Shape;293;p15">
+            <a:extLst>
+              <a:ext uri="{FF2B5EF4-FFF2-40B4-BE49-F238E27FC236}">
+                <a16:creationId xmlns:a16="http://schemas.microsoft.com/office/drawing/2014/main" id="{5E281CF7-024C-5473-8B4A-24A3CE2C1FCC}"/>
+              </a:ext>
+            </a:extLst>
+          </p:cNvPr>
+          <p:cNvSpPr txBox="1">
+            <a:spLocks/>
+          </p:cNvSpPr>
+          <p:nvPr/>
+        </p:nvSpPr>
+        <p:spPr>
+          <a:xfrm>
+            <a:off x="5208394" y="1597875"/>
+            <a:ext cx="3268201" cy="425186"/>
+          </a:xfrm>
+          <a:prstGeom prst="rect">
+            <a:avLst/>
+          </a:prstGeom>
+          <a:noFill/>
+          <a:ln>
+            <a:noFill/>
+          </a:ln>
+        </p:spPr>
+        <p:txBody>
+          <a:bodyPr spcFirstLastPara="1" wrap="square" lIns="91425" tIns="91425" rIns="91425" bIns="91425" anchor="t" anchorCtr="0">
+            <a:normAutofit fontScale="47500" lnSpcReduction="20000"/>
+          </a:bodyPr>
+          <a:lstStyle>
+            <a:defPPr marR="0" lvl="0" algn="l" rtl="0">
+              <a:lnSpc>
+                <a:spcPct val="100000"/>
+              </a:lnSpc>
+              <a:spcBef>
+                <a:spcPts val="0"/>
+              </a:spcBef>
+              <a:spcAft>
+                <a:spcPts val="0"/>
+              </a:spcAft>
+            </a:defPPr>
+            <a:lvl1pPr marR="0" lvl="0" algn="l" rtl="0">
+              <a:lnSpc>
+                <a:spcPct val="100000"/>
+              </a:lnSpc>
+              <a:spcBef>
+                <a:spcPts val="0"/>
+              </a:spcBef>
+              <a:spcAft>
+                <a:spcPts val="0"/>
+              </a:spcAft>
+              <a:buClr>
+                <a:schemeClr val="dk2"/>
+              </a:buClr>
+              <a:buSzPts val="2800"/>
+              <a:buFont typeface="Maven Pro"/>
+              <a:buNone/>
+              <a:defRPr sz="2800" b="1" i="0" u="none" strike="noStrike" cap="none">
+                <a:solidFill>
+                  <a:schemeClr val="dk2"/>
+                </a:solidFill>
+                <a:latin typeface="Maven Pro"/>
+                <a:ea typeface="Maven Pro"/>
+                <a:cs typeface="Maven Pro"/>
+                <a:sym typeface="Maven Pro"/>
+              </a:defRPr>
+            </a:lvl1pPr>
+            <a:lvl2pPr marR="0" lvl="1" algn="l" rtl="0">
+              <a:lnSpc>
+                <a:spcPct val="100000"/>
+              </a:lnSpc>
+              <a:spcBef>
+                <a:spcPts val="0"/>
+              </a:spcBef>
+              <a:spcAft>
+                <a:spcPts val="0"/>
+              </a:spcAft>
+              <a:buClr>
+                <a:schemeClr val="dk2"/>
+              </a:buClr>
+              <a:buSzPts val="2800"/>
+              <a:buFont typeface="Maven Pro"/>
+              <a:buNone/>
+              <a:defRPr sz="2800" b="1" i="0" u="none" strike="noStrike" cap="none">
+                <a:solidFill>
+                  <a:schemeClr val="dk2"/>
+                </a:solidFill>
+                <a:latin typeface="Maven Pro"/>
+                <a:ea typeface="Maven Pro"/>
+                <a:cs typeface="Maven Pro"/>
+                <a:sym typeface="Maven Pro"/>
+              </a:defRPr>
+            </a:lvl2pPr>
+            <a:lvl3pPr marR="0" lvl="2" algn="l" rtl="0">
+              <a:lnSpc>
+                <a:spcPct val="100000"/>
+              </a:lnSpc>
+              <a:spcBef>
+                <a:spcPts val="0"/>
+              </a:spcBef>
+              <a:spcAft>
+                <a:spcPts val="0"/>
+              </a:spcAft>
+              <a:buClr>
+                <a:schemeClr val="dk2"/>
+              </a:buClr>
+              <a:buSzPts val="2800"/>
+              <a:buFont typeface="Maven Pro"/>
+              <a:buNone/>
+              <a:defRPr sz="2800" b="1" i="0" u="none" strike="noStrike" cap="none">
+                <a:solidFill>
+                  <a:schemeClr val="dk2"/>
+                </a:solidFill>
+                <a:latin typeface="Maven Pro"/>
+                <a:ea typeface="Maven Pro"/>
+                <a:cs typeface="Maven Pro"/>
+                <a:sym typeface="Maven Pro"/>
+              </a:defRPr>
+            </a:lvl3pPr>
+            <a:lvl4pPr marR="0" lvl="3" algn="l" rtl="0">
+              <a:lnSpc>
+                <a:spcPct val="100000"/>
+              </a:lnSpc>
+              <a:spcBef>
+                <a:spcPts val="0"/>
+              </a:spcBef>
+              <a:spcAft>
+                <a:spcPts val="0"/>
+              </a:spcAft>
+              <a:buClr>
+                <a:schemeClr val="dk2"/>
+              </a:buClr>
+              <a:buSzPts val="2800"/>
+              <a:buFont typeface="Maven Pro"/>
+              <a:buNone/>
+              <a:defRPr sz="2800" b="1" i="0" u="none" strike="noStrike" cap="none">
+                <a:solidFill>
+                  <a:schemeClr val="dk2"/>
+                </a:solidFill>
+                <a:latin typeface="Maven Pro"/>
+                <a:ea typeface="Maven Pro"/>
+                <a:cs typeface="Maven Pro"/>
+                <a:sym typeface="Maven Pro"/>
+              </a:defRPr>
+            </a:lvl4pPr>
+            <a:lvl5pPr marR="0" lvl="4" algn="l" rtl="0">
+              <a:lnSpc>
+                <a:spcPct val="100000"/>
+              </a:lnSpc>
+              <a:spcBef>
+                <a:spcPts val="0"/>
+              </a:spcBef>
+              <a:spcAft>
+                <a:spcPts val="0"/>
+              </a:spcAft>
+              <a:buClr>
+                <a:schemeClr val="dk2"/>
+              </a:buClr>
+              <a:buSzPts val="2800"/>
+              <a:buFont typeface="Maven Pro"/>
+              <a:buNone/>
+              <a:defRPr sz="2800" b="1" i="0" u="none" strike="noStrike" cap="none">
+                <a:solidFill>
+                  <a:schemeClr val="dk2"/>
+                </a:solidFill>
+                <a:latin typeface="Maven Pro"/>
+                <a:ea typeface="Maven Pro"/>
+                <a:cs typeface="Maven Pro"/>
+                <a:sym typeface="Maven Pro"/>
+              </a:defRPr>
+            </a:lvl5pPr>
+            <a:lvl6pPr marR="0" lvl="5" algn="l" rtl="0">
+              <a:lnSpc>
+                <a:spcPct val="100000"/>
+              </a:lnSpc>
+              <a:spcBef>
+                <a:spcPts val="0"/>
+              </a:spcBef>
+              <a:spcAft>
+                <a:spcPts val="0"/>
+              </a:spcAft>
+              <a:buClr>
+                <a:schemeClr val="dk2"/>
+              </a:buClr>
+              <a:buSzPts val="2800"/>
+              <a:buFont typeface="Maven Pro"/>
+              <a:buNone/>
+              <a:defRPr sz="2800" b="1" i="0" u="none" strike="noStrike" cap="none">
+                <a:solidFill>
+                  <a:schemeClr val="dk2"/>
+                </a:solidFill>
+                <a:latin typeface="Maven Pro"/>
+                <a:ea typeface="Maven Pro"/>
+                <a:cs typeface="Maven Pro"/>
+                <a:sym typeface="Maven Pro"/>
+              </a:defRPr>
+            </a:lvl6pPr>
+            <a:lvl7pPr marR="0" lvl="6" algn="l" rtl="0">
+              <a:lnSpc>
+                <a:spcPct val="100000"/>
+              </a:lnSpc>
+              <a:spcBef>
+                <a:spcPts val="0"/>
+              </a:spcBef>
+              <a:spcAft>
+                <a:spcPts val="0"/>
+              </a:spcAft>
+              <a:buClr>
+                <a:schemeClr val="dk2"/>
+              </a:buClr>
+              <a:buSzPts val="2800"/>
+              <a:buFont typeface="Maven Pro"/>
+              <a:buNone/>
+              <a:defRPr sz="2800" b="1" i="0" u="none" strike="noStrike" cap="none">
+                <a:solidFill>
+                  <a:schemeClr val="dk2"/>
+                </a:solidFill>
+                <a:latin typeface="Maven Pro"/>
+                <a:ea typeface="Maven Pro"/>
+                <a:cs typeface="Maven Pro"/>
+                <a:sym typeface="Maven Pro"/>
+              </a:defRPr>
+            </a:lvl7pPr>
+            <a:lvl8pPr marR="0" lvl="7" algn="l" rtl="0">
+              <a:lnSpc>
+                <a:spcPct val="100000"/>
+              </a:lnSpc>
+              <a:spcBef>
+                <a:spcPts val="0"/>
+              </a:spcBef>
+              <a:spcAft>
+                <a:spcPts val="0"/>
+              </a:spcAft>
+              <a:buClr>
+                <a:schemeClr val="dk2"/>
+              </a:buClr>
+              <a:buSzPts val="2800"/>
+              <a:buFont typeface="Maven Pro"/>
+              <a:buNone/>
+              <a:defRPr sz="2800" b="1" i="0" u="none" strike="noStrike" cap="none">
+                <a:solidFill>
+                  <a:schemeClr val="dk2"/>
+                </a:solidFill>
+                <a:latin typeface="Maven Pro"/>
+                <a:ea typeface="Maven Pro"/>
+                <a:cs typeface="Maven Pro"/>
+                <a:sym typeface="Maven Pro"/>
+              </a:defRPr>
+            </a:lvl8pPr>
+            <a:lvl9pPr marR="0" lvl="8" algn="l" rtl="0">
+              <a:lnSpc>
+                <a:spcPct val="100000"/>
+              </a:lnSpc>
+              <a:spcBef>
+                <a:spcPts val="0"/>
+              </a:spcBef>
+              <a:spcAft>
+                <a:spcPts val="0"/>
+              </a:spcAft>
+              <a:buClr>
+                <a:schemeClr val="dk2"/>
+              </a:buClr>
+              <a:buSzPts val="2800"/>
+              <a:buFont typeface="Maven Pro"/>
+              <a:buNone/>
+              <a:defRPr sz="2800" b="1" i="0" u="none" strike="noStrike" cap="none">
+                <a:solidFill>
+                  <a:schemeClr val="dk2"/>
+                </a:solidFill>
+                <a:latin typeface="Maven Pro"/>
+                <a:ea typeface="Maven Pro"/>
+                <a:cs typeface="Maven Pro"/>
+                <a:sym typeface="Maven Pro"/>
+              </a:defRPr>
+            </a:lvl9pPr>
+          </a:lstStyle>
+          <a:p>
+            <a:r>
+              <a:rPr lang="es-ES" dirty="0"/>
+              <a:t>Script de seguimiento del Enemigo</a:t>
+            </a:r>
           </a:p>
         </p:txBody>
       </p:sp>
@@ -15918,15 +16550,11 @@
             </a:pPr>
             <a:r>
               <a:rPr lang="en-US" sz="1800" dirty="0" err="1"/>
-              <a:t>Eenemigos</a:t>
+              <a:t>Enemigos</a:t>
             </a:r>
             <a:r>
               <a:rPr lang="en-US" sz="1800" dirty="0"/>
-              <a:t>: Julio </a:t>
-            </a:r>
-            <a:r>
-              <a:rPr lang="en-US" sz="1800" dirty="0" err="1"/>
-              <a:t>Herraez</a:t>
+              <a:t>: Julio Herraez</a:t>
             </a:r>
             <a:endParaRPr lang="en-US" sz="1800" b="0" i="0" u="none" strike="noStrike" cap="none" dirty="0"/>
           </a:p>

</xml_diff>